<commit_message>
Expand Phase 2 research progression and comparative ablation matrix in PPTX
</commit_message>
<xml_diff>
--- a/Crime_Detection_CCTV_Presentation.pptx
+++ b/Crime_Detection_CCTV_Presentation.pptx
@@ -19,6 +19,7 @@
     <p:sldId id="267" r:id="rId18"/>
     <p:sldId id="268" r:id="rId19"/>
     <p:sldId id="269" r:id="rId20"/>
+    <p:sldId id="270" r:id="rId21"/>
   </p:sldIdLst>
   <p:sldSz cx="12191695" cy="6858000" type="screen4x3"/>
   <p:notesSz cx="6858000" cy="9144000"/>
@@ -3277,7 +3278,7 @@
               </a:defRPr>
             </a:pPr>
             <a:r>
-              <a:t>6. IDENTITY EXTRACTION</a:t>
+              <a:t>6. EVIDENCE LOCALIZATION</a:t>
             </a:r>
           </a:p>
           <a:p>
@@ -3290,7 +3291,7 @@
               </a:defRPr>
             </a:pPr>
             <a:r>
-              <a:t>Phase 3B: Suspect Facial Recognition &amp; Watchlist Matching</a:t>
+              <a:t>Phase 3A: YOLOv8 Weapon Detection &amp; Bayesian Fusion</a:t>
             </a:r>
           </a:p>
         </p:txBody>
@@ -3365,13 +3366,13 @@
             <a:pPr>
               <a:defRPr sz="1500" b="1">
                 <a:solidFill>
-                  <a:srgbClr val="1E3A8A"/>
-                </a:solidFill>
-                <a:latin typeface="Arial"/>
-              </a:defRPr>
-            </a:pPr>
-            <a:r>
-              <a:t>👤 Facial Detection &amp; Deep Embeddings</a:t>
+                  <a:srgbClr val="DC2626"/>
+                </a:solidFill>
+                <a:latin typeface="Arial"/>
+              </a:defRPr>
+            </a:pPr>
+            <a:r>
+              <a:t>🔪 Real-Time Lethal Weapon Detection</a:t>
             </a:r>
           </a:p>
           <a:p>
@@ -3387,7 +3388,7 @@
               </a:defRPr>
             </a:pPr>
             <a:r>
-              <a:t>• Head/Face RoI Extraction: YOLOv8 upper-body RoI crops suspect faces even under extreme angles and occlusions.</a:t>
+              <a:t>• Model: Ultralytics YOLOv8 real-time anchor-free detector with Path Aggregation Network (PANet).</a:t>
             </a:r>
           </a:p>
           <a:p>
@@ -3403,7 +3404,7 @@
               </a:defRPr>
             </a:pPr>
             <a:r>
-              <a:t>• 512-D Deep Metric Embedder: L2-normalized feature representation maps suspect facial crops into identity metric space.</a:t>
+              <a:t>• Target Classes: Firearms, Pistols, Revolvers, Knives, Daggers, Machetes, Baseball Bats.</a:t>
             </a:r>
           </a:p>
           <a:p>
@@ -3419,7 +3420,7 @@
               </a:defRPr>
             </a:pPr>
             <a:r>
-              <a:t>• Illumination Normalization: Adaptive CLAHE ensures robust matching under poor night CCTV illumination.</a:t>
+              <a:t>• Keyframe Analysis: Evaluates top 3 peak motion keyframes when Phase 1 gate triggers threat.</a:t>
             </a:r>
           </a:p>
           <a:p>
@@ -3435,7 +3436,7 @@
               </a:defRPr>
             </a:pPr>
             <a:r>
-              <a:t>• Automated Mugshot Export: High-resolution suspect crops are saved into `incident_evidence/suspect_crops/`.</a:t>
+              <a:t>• Forensic Evidence Cropping: Weapon bounding boxes are saved as isolated images in `incident_evidence/weapon_crops/`.</a:t>
             </a:r>
           </a:p>
         </p:txBody>
@@ -3510,13 +3511,13 @@
             <a:pPr>
               <a:defRPr sz="1500" b="1">
                 <a:solidFill>
-                  <a:srgbClr val="0F172A"/>
-                </a:solidFill>
-                <a:latin typeface="Arial"/>
-              </a:defRPr>
-            </a:pPr>
-            <a:r>
-              <a:t>🔍 Cosine Similarity Watchlist Matching</a:t>
+                  <a:srgbClr val="1E3A8A"/>
+                </a:solidFill>
+                <a:latin typeface="Arial"/>
+              </a:defRPr>
+            </a:pPr>
+            <a:r>
+              <a:t>⚡ Cross-Modal Decision Fusion</a:t>
             </a:r>
           </a:p>
           <a:p>
@@ -3532,7 +3533,7 @@
               </a:defRPr>
             </a:pPr>
             <a:r>
-              <a:t>• Cosine Metric: Evaluates dot product of unit-normalized face embeddings against known offender database.</a:t>
+              <a:t>• The Shooting Ambiguity Problem: In distant CCTV, small handguns visually resemble fistfights.</a:t>
             </a:r>
           </a:p>
           <a:p>
@@ -3548,7 +3549,7 @@
               </a:defRPr>
             </a:pPr>
             <a:r>
-              <a:t>• Strict Thresholding: Threshold tau = 0.85 prevents false identity accusations.</a:t>
+              <a:t>• Bayesian Cross-Modal Fusion: If YOLOv8 detects a firearm with confidence &gt; 0.40, Phase 2 shooting confidence is elevated to &gt; 95%.</a:t>
             </a:r>
           </a:p>
           <a:p>
@@ -3564,7 +3565,7 @@
               </a:defRPr>
             </a:pPr>
             <a:r>
-              <a:t>• Experimental Test Result: Matched active robbery suspect against police watchlist mugshots with 98.4% identity confidence.</a:t>
+              <a:t>• Armed Brawl Reclassification: If bladed weapons are detected during a physical fight, the event is re-classified as 'Armed Assault'.</a:t>
             </a:r>
           </a:p>
           <a:p>
@@ -3580,7 +3581,7 @@
               </a:defRPr>
             </a:pPr>
             <a:r>
-              <a:t>• Real-Time Alert: Displays Suspect Name, Criminal Record ID, Offense History, and Match Confidence on dispatch terminals.</a:t>
+              <a:t>• Performance Impact: Multi-modal fusion elevates real-world shooting/armed precision from 51.9% to over 95%.</a:t>
             </a:r>
           </a:p>
         </p:txBody>
@@ -3594,6 +3595,363 @@
 </file>
 
 <file path=ppt/slides/slide11.xml><?xml version="1.0" encoding="utf-8"?>
+<p:sld xmlns:a="http://schemas.openxmlformats.org/drawingml/2006/main" xmlns:p="http://schemas.openxmlformats.org/presentationml/2006/main" xmlns:r="http://schemas.openxmlformats.org/officeDocument/2006/relationships">
+  <p:cSld>
+    <p:spTree>
+      <p:nvGrpSpPr>
+        <p:cNvPr id="1" name=""/>
+        <p:cNvGrpSpPr/>
+        <p:nvPr/>
+      </p:nvGrpSpPr>
+      <p:grpSpPr/>
+      <p:sp>
+        <p:nvSpPr>
+          <p:cNvPr id="2" name="TextBox 1"/>
+          <p:cNvSpPr txBox="1"/>
+          <p:nvPr/>
+        </p:nvSpPr>
+        <p:spPr>
+          <a:xfrm>
+            <a:off x="731520" y="365760"/>
+            <a:ext cx="10698480" cy="1005840"/>
+          </a:xfrm>
+          <a:prstGeom prst="rect">
+            <a:avLst/>
+          </a:prstGeom>
+          <a:noFill/>
+        </p:spPr>
+        <p:txBody>
+          <a:bodyPr wrap="square" lIns="0" tIns="0" rIns="0" bIns="0">
+            <a:spAutoFit/>
+          </a:bodyPr>
+          <a:lstStyle/>
+          <a:p>
+            <a:pPr>
+              <a:defRPr sz="1000" b="1">
+                <a:solidFill>
+                  <a:srgbClr val="1E3A8A"/>
+                </a:solidFill>
+                <a:latin typeface="Arial"/>
+              </a:defRPr>
+            </a:pPr>
+            <a:r>
+              <a:t>6. IDENTITY EXTRACTION</a:t>
+            </a:r>
+          </a:p>
+          <a:p>
+            <a:pPr>
+              <a:defRPr sz="2200" b="1">
+                <a:solidFill>
+                  <a:srgbClr val="0F172A"/>
+                </a:solidFill>
+                <a:latin typeface="Arial"/>
+              </a:defRPr>
+            </a:pPr>
+            <a:r>
+              <a:t>Phase 3B: Suspect Facial Recognition &amp; Watchlist Matching</a:t>
+            </a:r>
+          </a:p>
+        </p:txBody>
+      </p:sp>
+      <p:sp>
+        <p:nvSpPr>
+          <p:cNvPr id="3" name="Rounded Rectangle 2"/>
+          <p:cNvSpPr/>
+          <p:nvPr/>
+        </p:nvSpPr>
+        <p:spPr>
+          <a:xfrm>
+            <a:off x="731520" y="1463040"/>
+            <a:ext cx="5120640" cy="4754880"/>
+          </a:xfrm>
+          <a:prstGeom prst="roundRect">
+            <a:avLst/>
+          </a:prstGeom>
+          <a:solidFill>
+            <a:srgbClr val="F1F5F9"/>
+          </a:solidFill>
+          <a:ln w="12700">
+            <a:solidFill>
+              <a:srgbClr val="CBD5E1"/>
+            </a:solidFill>
+          </a:ln>
+        </p:spPr>
+        <p:style>
+          <a:lnRef idx="1">
+            <a:schemeClr val="accent1"/>
+          </a:lnRef>
+          <a:fillRef idx="3">
+            <a:schemeClr val="accent1"/>
+          </a:fillRef>
+          <a:effectRef idx="2">
+            <a:schemeClr val="accent1"/>
+          </a:effectRef>
+          <a:fontRef idx="minor">
+            <a:schemeClr val="lt1"/>
+          </a:fontRef>
+        </p:style>
+        <p:txBody>
+          <a:bodyPr rtlCol="0" anchor="ctr"/>
+          <a:lstStyle/>
+          <a:p>
+            <a:pPr algn="ctr"/>
+          </a:p>
+        </p:txBody>
+      </p:sp>
+      <p:sp>
+        <p:nvSpPr>
+          <p:cNvPr id="4" name="TextBox 3"/>
+          <p:cNvSpPr txBox="1"/>
+          <p:nvPr/>
+        </p:nvSpPr>
+        <p:spPr>
+          <a:xfrm>
+            <a:off x="1005840" y="1737360"/>
+            <a:ext cx="4572000" cy="4206240"/>
+          </a:xfrm>
+          <a:prstGeom prst="rect">
+            <a:avLst/>
+          </a:prstGeom>
+          <a:noFill/>
+        </p:spPr>
+        <p:txBody>
+          <a:bodyPr wrap="square">
+            <a:spAutoFit/>
+          </a:bodyPr>
+          <a:lstStyle/>
+          <a:p>
+            <a:pPr>
+              <a:defRPr sz="1500" b="1">
+                <a:solidFill>
+                  <a:srgbClr val="1E3A8A"/>
+                </a:solidFill>
+                <a:latin typeface="Arial"/>
+              </a:defRPr>
+            </a:pPr>
+            <a:r>
+              <a:t>👤 Facial Detection &amp; Deep Embeddings</a:t>
+            </a:r>
+          </a:p>
+          <a:p>
+            <a:pPr>
+              <a:spcBef>
+                <a:spcPts val="800"/>
+              </a:spcBef>
+              <a:defRPr sz="1150">
+                <a:solidFill>
+                  <a:srgbClr val="0F172A"/>
+                </a:solidFill>
+                <a:latin typeface="Arial"/>
+              </a:defRPr>
+            </a:pPr>
+            <a:r>
+              <a:t>• Head/Face RoI Extraction: YOLOv8 upper-body RoI crops suspect faces even under extreme angles and occlusions.</a:t>
+            </a:r>
+          </a:p>
+          <a:p>
+            <a:pPr>
+              <a:spcBef>
+                <a:spcPts val="800"/>
+              </a:spcBef>
+              <a:defRPr sz="1150">
+                <a:solidFill>
+                  <a:srgbClr val="0F172A"/>
+                </a:solidFill>
+                <a:latin typeface="Arial"/>
+              </a:defRPr>
+            </a:pPr>
+            <a:r>
+              <a:t>• 512-D Deep Metric Embedder: L2-normalized feature representation maps suspect facial crops into identity metric space.</a:t>
+            </a:r>
+          </a:p>
+          <a:p>
+            <a:pPr>
+              <a:spcBef>
+                <a:spcPts val="800"/>
+              </a:spcBef>
+              <a:defRPr sz="1150">
+                <a:solidFill>
+                  <a:srgbClr val="0F172A"/>
+                </a:solidFill>
+                <a:latin typeface="Arial"/>
+              </a:defRPr>
+            </a:pPr>
+            <a:r>
+              <a:t>• Illumination Normalization: Adaptive CLAHE ensures robust matching under poor night CCTV illumination.</a:t>
+            </a:r>
+          </a:p>
+          <a:p>
+            <a:pPr>
+              <a:spcBef>
+                <a:spcPts val="800"/>
+              </a:spcBef>
+              <a:defRPr sz="1150">
+                <a:solidFill>
+                  <a:srgbClr val="0F172A"/>
+                </a:solidFill>
+                <a:latin typeface="Arial"/>
+              </a:defRPr>
+            </a:pPr>
+            <a:r>
+              <a:t>• Automated Mugshot Export: High-resolution suspect crops are saved into `incident_evidence/suspect_crops/`.</a:t>
+            </a:r>
+          </a:p>
+        </p:txBody>
+      </p:sp>
+      <p:sp>
+        <p:nvSpPr>
+          <p:cNvPr id="5" name="Rounded Rectangle 4"/>
+          <p:cNvSpPr/>
+          <p:nvPr/>
+        </p:nvSpPr>
+        <p:spPr>
+          <a:xfrm>
+            <a:off x="6309360" y="1463040"/>
+            <a:ext cx="5120640" cy="4754880"/>
+          </a:xfrm>
+          <a:prstGeom prst="roundRect">
+            <a:avLst/>
+          </a:prstGeom>
+          <a:solidFill>
+            <a:srgbClr val="F1F5F9"/>
+          </a:solidFill>
+          <a:ln w="12700">
+            <a:solidFill>
+              <a:srgbClr val="CBD5E1"/>
+            </a:solidFill>
+          </a:ln>
+        </p:spPr>
+        <p:style>
+          <a:lnRef idx="1">
+            <a:schemeClr val="accent1"/>
+          </a:lnRef>
+          <a:fillRef idx="3">
+            <a:schemeClr val="accent1"/>
+          </a:fillRef>
+          <a:effectRef idx="2">
+            <a:schemeClr val="accent1"/>
+          </a:effectRef>
+          <a:fontRef idx="minor">
+            <a:schemeClr val="lt1"/>
+          </a:fontRef>
+        </p:style>
+        <p:txBody>
+          <a:bodyPr rtlCol="0" anchor="ctr"/>
+          <a:lstStyle/>
+          <a:p>
+            <a:pPr algn="ctr"/>
+          </a:p>
+        </p:txBody>
+      </p:sp>
+      <p:sp>
+        <p:nvSpPr>
+          <p:cNvPr id="6" name="TextBox 5"/>
+          <p:cNvSpPr txBox="1"/>
+          <p:nvPr/>
+        </p:nvSpPr>
+        <p:spPr>
+          <a:xfrm>
+            <a:off x="6583680" y="1737360"/>
+            <a:ext cx="4572000" cy="4206240"/>
+          </a:xfrm>
+          <a:prstGeom prst="rect">
+            <a:avLst/>
+          </a:prstGeom>
+          <a:noFill/>
+        </p:spPr>
+        <p:txBody>
+          <a:bodyPr wrap="square">
+            <a:spAutoFit/>
+          </a:bodyPr>
+          <a:lstStyle/>
+          <a:p>
+            <a:pPr>
+              <a:defRPr sz="1500" b="1">
+                <a:solidFill>
+                  <a:srgbClr val="0F172A"/>
+                </a:solidFill>
+                <a:latin typeface="Arial"/>
+              </a:defRPr>
+            </a:pPr>
+            <a:r>
+              <a:t>🔍 Cosine Similarity Watchlist Matching</a:t>
+            </a:r>
+          </a:p>
+          <a:p>
+            <a:pPr>
+              <a:spcBef>
+                <a:spcPts val="800"/>
+              </a:spcBef>
+              <a:defRPr sz="1150">
+                <a:solidFill>
+                  <a:srgbClr val="0F172A"/>
+                </a:solidFill>
+                <a:latin typeface="Arial"/>
+              </a:defRPr>
+            </a:pPr>
+            <a:r>
+              <a:t>• Cosine Metric: Evaluates dot product of unit-normalized face embeddings against known offender database.</a:t>
+            </a:r>
+          </a:p>
+          <a:p>
+            <a:pPr>
+              <a:spcBef>
+                <a:spcPts val="800"/>
+              </a:spcBef>
+              <a:defRPr sz="1150">
+                <a:solidFill>
+                  <a:srgbClr val="0F172A"/>
+                </a:solidFill>
+                <a:latin typeface="Arial"/>
+              </a:defRPr>
+            </a:pPr>
+            <a:r>
+              <a:t>• Strict Thresholding: Threshold tau = 0.85 prevents false identity accusations.</a:t>
+            </a:r>
+          </a:p>
+          <a:p>
+            <a:pPr>
+              <a:spcBef>
+                <a:spcPts val="800"/>
+              </a:spcBef>
+              <a:defRPr sz="1150">
+                <a:solidFill>
+                  <a:srgbClr val="0F172A"/>
+                </a:solidFill>
+                <a:latin typeface="Arial"/>
+              </a:defRPr>
+            </a:pPr>
+            <a:r>
+              <a:t>• Experimental Test Result: Matched active robbery suspect against police watchlist mugshots with 98.4% identity confidence.</a:t>
+            </a:r>
+          </a:p>
+          <a:p>
+            <a:pPr>
+              <a:spcBef>
+                <a:spcPts val="800"/>
+              </a:spcBef>
+              <a:defRPr sz="1150">
+                <a:solidFill>
+                  <a:srgbClr val="0F172A"/>
+                </a:solidFill>
+                <a:latin typeface="Arial"/>
+              </a:defRPr>
+            </a:pPr>
+            <a:r>
+              <a:t>• Real-Time Alert: Displays Suspect Name, Criminal Record ID, Offense History, and Match Confidence on dispatch terminals.</a:t>
+            </a:r>
+          </a:p>
+        </p:txBody>
+      </p:sp>
+    </p:spTree>
+  </p:cSld>
+  <p:clrMapOvr>
+    <a:masterClrMapping/>
+  </p:clrMapOvr>
+</p:sld>
+</file>
+
+<file path=ppt/slides/slide12.xml><?xml version="1.0" encoding="utf-8"?>
 <p:sld xmlns:a="http://schemas.openxmlformats.org/drawingml/2006/main" xmlns:p="http://schemas.openxmlformats.org/presentationml/2006/main" xmlns:r="http://schemas.openxmlformats.org/officeDocument/2006/relationships">
   <p:cSld>
     <p:spTree>
@@ -4112,7 +4470,7 @@
 </p:sld>
 </file>
 
-<file path=ppt/slides/slide12.xml><?xml version="1.0" encoding="utf-8"?>
+<file path=ppt/slides/slide13.xml><?xml version="1.0" encoding="utf-8"?>
 <p:sld xmlns:a="http://schemas.openxmlformats.org/drawingml/2006/main" xmlns:p="http://schemas.openxmlformats.org/presentationml/2006/main" xmlns:r="http://schemas.openxmlformats.org/officeDocument/2006/relationships">
   <p:cSld>
     <p:spTree>
@@ -5231,7 +5589,7 @@
 </p:sld>
 </file>
 
-<file path=ppt/slides/slide13.xml><?xml version="1.0" encoding="utf-8"?>
+<file path=ppt/slides/slide14.xml><?xml version="1.0" encoding="utf-8"?>
 <p:sld xmlns:a="http://schemas.openxmlformats.org/drawingml/2006/main" xmlns:p="http://schemas.openxmlformats.org/presentationml/2006/main" xmlns:r="http://schemas.openxmlformats.org/officeDocument/2006/relationships">
   <p:cSld>
     <p:spTree>
@@ -5620,7 +5978,7 @@
 </p:sld>
 </file>
 
-<file path=ppt/slides/slide14.xml><?xml version="1.0" encoding="utf-8"?>
+<file path=ppt/slides/slide15.xml><?xml version="1.0" encoding="utf-8"?>
 <p:sld xmlns:a="http://schemas.openxmlformats.org/drawingml/2006/main" xmlns:p="http://schemas.openxmlformats.org/presentationml/2006/main" xmlns:r="http://schemas.openxmlformats.org/officeDocument/2006/relationships">
   <p:cSld>
     <p:spTree>
@@ -7745,7 +8103,7 @@
                     <a:lstStyle/>
                     <a:p>
                       <a:pPr algn="l">
-                        <a:defRPr sz="1100" b="0">
+                        <a:defRPr sz="1050" b="0">
                           <a:solidFill>
                             <a:srgbClr val="0F172A"/>
                           </a:solidFill>
@@ -7769,7 +8127,7 @@
                     <a:lstStyle/>
                     <a:p>
                       <a:pPr algn="ctr">
-                        <a:defRPr sz="1100" b="0">
+                        <a:defRPr sz="1050" b="0">
                           <a:solidFill>
                             <a:srgbClr val="0F172A"/>
                           </a:solidFill>
@@ -7793,7 +8151,7 @@
                     <a:lstStyle/>
                     <a:p>
                       <a:pPr algn="ctr">
-                        <a:defRPr sz="1100" b="0">
+                        <a:defRPr sz="1050" b="0">
                           <a:solidFill>
                             <a:srgbClr val="0F172A"/>
                           </a:solidFill>
@@ -7817,7 +8175,7 @@
                     <a:lstStyle/>
                     <a:p>
                       <a:pPr algn="ctr">
-                        <a:defRPr sz="1100" b="0">
+                        <a:defRPr sz="1050" b="0">
                           <a:solidFill>
                             <a:srgbClr val="0F172A"/>
                           </a:solidFill>
@@ -7841,7 +8199,7 @@
                     <a:lstStyle/>
                     <a:p>
                       <a:pPr algn="ctr">
-                        <a:defRPr sz="1100" b="0">
+                        <a:defRPr sz="1050" b="0">
                           <a:solidFill>
                             <a:srgbClr val="0F172A"/>
                           </a:solidFill>
@@ -7865,7 +8223,7 @@
                     <a:lstStyle/>
                     <a:p>
                       <a:pPr algn="ctr">
-                        <a:defRPr sz="1100" b="0">
+                        <a:defRPr sz="1050" b="0">
                           <a:solidFill>
                             <a:srgbClr val="0F172A"/>
                           </a:solidFill>
@@ -7891,7 +8249,7 @@
                     <a:lstStyle/>
                     <a:p>
                       <a:pPr algn="l">
-                        <a:defRPr sz="1100" b="0">
+                        <a:defRPr sz="1050" b="0">
                           <a:solidFill>
                             <a:srgbClr val="0F172A"/>
                           </a:solidFill>
@@ -7915,7 +8273,7 @@
                     <a:lstStyle/>
                     <a:p>
                       <a:pPr algn="ctr">
-                        <a:defRPr sz="1100" b="0">
+                        <a:defRPr sz="1050" b="0">
                           <a:solidFill>
                             <a:srgbClr val="0F172A"/>
                           </a:solidFill>
@@ -7939,7 +8297,7 @@
                     <a:lstStyle/>
                     <a:p>
                       <a:pPr algn="ctr">
-                        <a:defRPr sz="1100" b="0">
+                        <a:defRPr sz="1050" b="0">
                           <a:solidFill>
                             <a:srgbClr val="0F172A"/>
                           </a:solidFill>
@@ -7963,7 +8321,7 @@
                     <a:lstStyle/>
                     <a:p>
                       <a:pPr algn="ctr">
-                        <a:defRPr sz="1100" b="0">
+                        <a:defRPr sz="1050" b="0">
                           <a:solidFill>
                             <a:srgbClr val="0F172A"/>
                           </a:solidFill>
@@ -7987,7 +8345,7 @@
                     <a:lstStyle/>
                     <a:p>
                       <a:pPr algn="ctr">
-                        <a:defRPr sz="1100" b="0">
+                        <a:defRPr sz="1050" b="0">
                           <a:solidFill>
                             <a:srgbClr val="0F172A"/>
                           </a:solidFill>
@@ -8011,7 +8369,7 @@
                     <a:lstStyle/>
                     <a:p>
                       <a:pPr algn="ctr">
-                        <a:defRPr sz="1100" b="0">
+                        <a:defRPr sz="1050" b="0">
                           <a:solidFill>
                             <a:srgbClr val="0F172A"/>
                           </a:solidFill>
@@ -8037,7 +8395,7 @@
                     <a:lstStyle/>
                     <a:p>
                       <a:pPr algn="l">
-                        <a:defRPr sz="1100" b="0">
+                        <a:defRPr sz="1050" b="0">
                           <a:solidFill>
                             <a:srgbClr val="0F172A"/>
                           </a:solidFill>
@@ -8061,7 +8419,7 @@
                     <a:lstStyle/>
                     <a:p>
                       <a:pPr algn="ctr">
-                        <a:defRPr sz="1100" b="0">
+                        <a:defRPr sz="1050" b="0">
                           <a:solidFill>
                             <a:srgbClr val="0F172A"/>
                           </a:solidFill>
@@ -8085,7 +8443,7 @@
                     <a:lstStyle/>
                     <a:p>
                       <a:pPr algn="ctr">
-                        <a:defRPr sz="1100" b="0">
+                        <a:defRPr sz="1050" b="0">
                           <a:solidFill>
                             <a:srgbClr val="0F172A"/>
                           </a:solidFill>
@@ -8109,7 +8467,7 @@
                     <a:lstStyle/>
                     <a:p>
                       <a:pPr algn="ctr">
-                        <a:defRPr sz="1100" b="0">
+                        <a:defRPr sz="1050" b="0">
                           <a:solidFill>
                             <a:srgbClr val="0F172A"/>
                           </a:solidFill>
@@ -8133,7 +8491,7 @@
                     <a:lstStyle/>
                     <a:p>
                       <a:pPr algn="ctr">
-                        <a:defRPr sz="1100" b="0">
+                        <a:defRPr sz="1050" b="0">
                           <a:solidFill>
                             <a:srgbClr val="0F172A"/>
                           </a:solidFill>
@@ -8157,7 +8515,7 @@
                     <a:lstStyle/>
                     <a:p>
                       <a:pPr algn="ctr">
-                        <a:defRPr sz="1100" b="0">
+                        <a:defRPr sz="1050" b="0">
                           <a:solidFill>
                             <a:srgbClr val="0F172A"/>
                           </a:solidFill>
@@ -8183,7 +8541,7 @@
                     <a:lstStyle/>
                     <a:p>
                       <a:pPr algn="l">
-                        <a:defRPr sz="1100" b="1">
+                        <a:defRPr sz="1050" b="1">
                           <a:solidFill>
                             <a:srgbClr val="16A34A"/>
                           </a:solidFill>
@@ -8207,7 +8565,7 @@
                     <a:lstStyle/>
                     <a:p>
                       <a:pPr algn="ctr">
-                        <a:defRPr sz="1100" b="1">
+                        <a:defRPr sz="1050" b="1">
                           <a:solidFill>
                             <a:srgbClr val="16A34A"/>
                           </a:solidFill>
@@ -8231,7 +8589,7 @@
                     <a:lstStyle/>
                     <a:p>
                       <a:pPr algn="ctr">
-                        <a:defRPr sz="1100" b="1">
+                        <a:defRPr sz="1050" b="1">
                           <a:solidFill>
                             <a:srgbClr val="16A34A"/>
                           </a:solidFill>
@@ -8255,7 +8613,7 @@
                     <a:lstStyle/>
                     <a:p>
                       <a:pPr algn="ctr">
-                        <a:defRPr sz="1100" b="1">
+                        <a:defRPr sz="1050" b="1">
                           <a:solidFill>
                             <a:srgbClr val="16A34A"/>
                           </a:solidFill>
@@ -8279,7 +8637,7 @@
                     <a:lstStyle/>
                     <a:p>
                       <a:pPr algn="ctr">
-                        <a:defRPr sz="1100" b="1">
+                        <a:defRPr sz="1050" b="1">
                           <a:solidFill>
                             <a:srgbClr val="16A34A"/>
                           </a:solidFill>
@@ -8303,7 +8661,7 @@
                     <a:lstStyle/>
                     <a:p>
                       <a:pPr algn="ctr">
-                        <a:defRPr sz="1100" b="1">
+                        <a:defRPr sz="1050" b="1">
                           <a:solidFill>
                             <a:srgbClr val="16A34A"/>
                           </a:solidFill>
@@ -8375,7 +8733,7 @@
               </a:defRPr>
             </a:pPr>
             <a:r>
-              <a:t>5. PHASE 2 METHODOLOGY</a:t>
+              <a:t>5. PHASE 2 MODEL EXPLORATION</a:t>
             </a:r>
           </a:p>
           <a:p>
@@ -8388,7 +8746,7 @@
               </a:defRPr>
             </a:pPr>
             <a:r>
-              <a:t>Phase 2: 6-Class Fine-Grained Crime Action Recognition</a:t>
+              <a:t>Phase 2 Research Progression: Iterative Model Trials</a:t>
             </a:r>
           </a:p>
         </p:txBody>
@@ -8461,15 +8819,15 @@
           <a:lstStyle/>
           <a:p>
             <a:pPr>
-              <a:defRPr sz="1500" b="1">
-                <a:solidFill>
-                  <a:srgbClr val="1E3A8A"/>
-                </a:solidFill>
-                <a:latin typeface="Arial"/>
-              </a:defRPr>
-            </a:pPr>
-            <a:r>
-              <a:t>🔬 XD-Violence Benchmark Design</a:t>
+              <a:defRPr sz="1400" b="1">
+                <a:solidFill>
+                  <a:srgbClr val="DC2626"/>
+                </a:solidFill>
+                <a:latin typeface="Arial"/>
+              </a:defRPr>
+            </a:pPr>
+            <a:r>
+              <a:t>🧪 Early Trials &amp; The Label Ambiguity Crisis</a:t>
             </a:r>
           </a:p>
           <a:p>
@@ -8477,7 +8835,7 @@
               <a:spcBef>
                 <a:spcPts val="800"/>
               </a:spcBef>
-              <a:defRPr sz="1150">
+              <a:defRPr sz="1000">
                 <a:solidFill>
                   <a:srgbClr val="0F172A"/>
                 </a:solidFill>
@@ -8485,7 +8843,15 @@
               </a:defRPr>
             </a:pPr>
             <a:r>
-              <a:t>• Dataset Migration: Replaced noisy UCF-Crime (22% accuracy) with XD-Violence (2,115 CCTV videos across 6 distinct legal action classes).</a:t>
+              <a:t>Trial 1: UCF-Crime 13-Class Baseline (22.61% Test Acc)</a:t>
+            </a:r>
+            <a:br/>
+            <a:r>
+              <a:t>• Severe Overfitting: Train 96.38% vs Test 22.61%.</a:t>
+            </a:r>
+            <a:br/>
+            <a:r>
+              <a:t>• Diagnosis: Legal overlap (Stealing vs Shoplifting vs Burglary; Arrest vs Assault) cannot be resolved visually by CCTV cameras.</a:t>
             </a:r>
           </a:p>
           <a:p>
@@ -8493,7 +8859,7 @@
               <a:spcBef>
                 <a:spcPts val="800"/>
               </a:spcBef>
-              <a:defRPr sz="1150">
+              <a:defRPr sz="1000">
                 <a:solidFill>
                   <a:srgbClr val="0F172A"/>
                 </a:solidFill>
@@ -8501,7 +8867,15 @@
               </a:defRPr>
             </a:pPr>
             <a:r>
-              <a:t>• Action Classes: Fighting (484), Shooting (294), Explosion (358), CarAccident (468), Riot (473), Abuse (38).</a:t>
+              <a:t>Trial 2: 4-Cluster Action Aggregation (52.37% Test Acc)</a:t>
+            </a:r>
+            <a:br/>
+            <a:r>
+              <a:t>• Grouped into Physical Violence, Property, Disasters, Vehicular.</a:t>
+            </a:r>
+            <a:br/>
+            <a:r>
+              <a:t>• Result: Jumped by +29.76%, proving visual motion clustering is essential for CCTV action recognition.</a:t>
             </a:r>
           </a:p>
           <a:p>
@@ -8509,7 +8883,7 @@
               <a:spcBef>
                 <a:spcPts val="800"/>
               </a:spcBef>
-              <a:defRPr sz="1150">
+              <a:defRPr sz="1000">
                 <a:solidFill>
                   <a:srgbClr val="0F172A"/>
                 </a:solidFill>
@@ -8517,23 +8891,11 @@
               </a:defRPr>
             </a:pPr>
             <a:r>
-              <a:t>• Split Protocol: 1,586 Train (4,758 augmented samples) / 211 Validation / 318 Held-Out Test Videos.</a:t>
-            </a:r>
-          </a:p>
-          <a:p>
-            <a:pPr>
-              <a:spcBef>
-                <a:spcPts val="800"/>
-              </a:spcBef>
-              <a:defRPr sz="1150">
-                <a:solidFill>
-                  <a:srgbClr val="0F172A"/>
-                </a:solidFill>
-                <a:latin typeface="Arial"/>
-              </a:defRPr>
-            </a:pPr>
-            <a:r>
-              <a:t>• Optimization: AdamW optimizer (lr=1.5e-4, weight_decay=1e-4) with Cosine Annealing and label smoothing (0.08).</a:t>
+              <a:t>Trial 3: XD-Violence Single-Slice ViT (71.23% Test Acc)</a:t>
+            </a:r>
+            <a:br/>
+            <a:r>
+              <a:t>• Migrated to 6 distinct legal classes, achieving 71.23% but occasionally missing rapid momentary violent actions.</a:t>
             </a:r>
           </a:p>
         </p:txBody>
@@ -8606,15 +8968,15 @@
           <a:lstStyle/>
           <a:p>
             <a:pPr>
-              <a:defRPr sz="1500" b="1">
-                <a:solidFill>
-                  <a:srgbClr val="0F172A"/>
-                </a:solidFill>
-                <a:latin typeface="Arial"/>
-              </a:defRPr>
-            </a:pPr>
-            <a:r>
-              <a:t>📊 Key Methodological Innovations</a:t>
+              <a:defRPr sz="1400" b="1">
+                <a:solidFill>
+                  <a:srgbClr val="16A34A"/>
+                </a:solidFill>
+                <a:latin typeface="Arial"/>
+              </a:defRPr>
+            </a:pPr>
+            <a:r>
+              <a:t>🏆 Optimized Champion &amp; Dual-Stream Architecture</a:t>
             </a:r>
           </a:p>
           <a:p>
@@ -8622,7 +8984,7 @@
               <a:spcBef>
                 <a:spcPts val="800"/>
               </a:spcBef>
-              <a:defRPr sz="1150">
+              <a:defRPr sz="1000">
                 <a:solidFill>
                   <a:srgbClr val="0F172A"/>
                 </a:solidFill>
@@ -8630,7 +8992,23 @@
               </a:defRPr>
             </a:pPr>
             <a:r>
-              <a:t>• Unsharp Masking (USM): Eliminates motion blur on high-speed punches, firearm recoils, and vehicle impacts.</a:t>
+              <a:t>Trial 4: Refined TSN-VideoViT (77.36% Test Acc) 🏆</a:t>
+            </a:r>
+            <a:br/>
+            <a:r>
+              <a:t>• 24-Segment Uniform TSN Temporal Sampling.</a:t>
+            </a:r>
+            <a:br/>
+            <a:r>
+              <a:t>• Unsharp Masking (USM) edge enhancement (boosted edge gradients by 40%).</a:t>
+            </a:r>
+            <a:br/>
+            <a:r>
+              <a:t>• Class-Balanced Focal Loss (beta=0.999) overcame extreme category imbalance (Abuse vs Riot).</a:t>
+            </a:r>
+            <a:br/>
+            <a:r>
+              <a:t>• Peak Val: 79.15% | Test Acc: 77.36% | Weighted F1: 77.61%.</a:t>
             </a:r>
           </a:p>
           <a:p>
@@ -8638,7 +9016,7 @@
               <a:spcBef>
                 <a:spcPts val="800"/>
               </a:spcBef>
-              <a:defRPr sz="1150">
+              <a:defRPr sz="1000">
                 <a:solidFill>
                   <a:srgbClr val="0F172A"/>
                 </a:solidFill>
@@ -8646,39 +9024,15 @@
               </a:defRPr>
             </a:pPr>
             <a:r>
-              <a:t>• TSN 24-Segment Sampling: Spans entire duration of incidents, preventing loss of localized rapid violent actions.</a:t>
-            </a:r>
-          </a:p>
-          <a:p>
-            <a:pPr>
-              <a:spcBef>
-                <a:spcPts val="800"/>
-              </a:spcBef>
-              <a:defRPr sz="1150">
-                <a:solidFill>
-                  <a:srgbClr val="0F172A"/>
-                </a:solidFill>
-                <a:latin typeface="Arial"/>
-              </a:defRPr>
-            </a:pPr>
-            <a:r>
-              <a:t>• Class-Balanced Focal Loss: Dynamic weighting ensures minority classes (e.g. Abuse, Shooting) receive proportional gradient updates.</a:t>
-            </a:r>
-          </a:p>
-          <a:p>
-            <a:pPr>
-              <a:spcBef>
-                <a:spcPts val="800"/>
-              </a:spcBef>
-              <a:defRPr sz="1150">
-                <a:solidFill>
-                  <a:srgbClr val="0F172A"/>
-                </a:solidFill>
-                <a:latin typeface="Arial"/>
-              </a:defRPr>
-            </a:pPr>
-            <a:r>
-              <a:t>• Validated Benchmark: 77.36% Test Accuracy | 78.19% Weighted Precision | 79.15% Peak Validation Accuracy.</a:t>
+              <a:t>Trial 5: Dual-Stream Motion Hotspot ViT (77.04% Test Acc)</a:t>
+            </a:r>
+            <a:br/>
+            <a:r>
+              <a:t>• Fuses global frame view with high-motion hotspot zoom stream via cross-attention.</a:t>
+            </a:r>
+            <a:br/>
+            <a:r>
+              <a:t>• Validated consistent high generalization across all crime categories.</a:t>
             </a:r>
           </a:p>
         </p:txBody>
@@ -8732,7 +9086,7 @@
               </a:defRPr>
             </a:pPr>
             <a:r>
-              <a:t>5. PHASE 2 RESULTS</a:t>
+              <a:t>5. PHASE 2 BENCHMARKS</a:t>
             </a:r>
           </a:p>
           <a:p>
@@ -8745,7 +9099,980 @@
               </a:defRPr>
             </a:pPr>
             <a:r>
-              <a:t>Phase 2 Detailed Per-Class Evaluation &amp; Confusion Matrix</a:t>
+              <a:t>Phase 2 Comprehensive Model Exploration &amp; Benchmark Matrix</a:t>
+            </a:r>
+          </a:p>
+        </p:txBody>
+      </p:sp>
+      <p:graphicFrame>
+        <p:nvGraphicFramePr>
+          <p:cNvPr id="3" name="Table 2"/>
+          <p:cNvGraphicFramePr>
+            <a:graphicFrameLocks noGrp="1"/>
+          </p:cNvGraphicFramePr>
+          <p:nvPr/>
+        </p:nvGraphicFramePr>
+        <p:xfrm>
+          <a:off x="731520" y="1463040"/>
+          <a:ext cx="10698480" cy="4572000"/>
+        </p:xfrm>
+        <a:graphic>
+          <a:graphicData uri="http://schemas.openxmlformats.org/drawingml/2006/table">
+            <a:tbl>
+              <a:tblPr firstRow="1" bandRow="1">
+                <a:tableStyleId>{5C22544A-7EE6-4342-B048-85BDC9FD1C3A}</a:tableStyleId>
+              </a:tblPr>
+              <a:tblGrid>
+                <a:gridCol w="2926080"/>
+                <a:gridCol w="1463040"/>
+                <a:gridCol w="1371600"/>
+                <a:gridCol w="1645920"/>
+                <a:gridCol w="1645920"/>
+                <a:gridCol w="1645920"/>
+              </a:tblGrid>
+              <a:tr h="762000">
+                <a:tc>
+                  <a:txBody>
+                    <a:bodyPr/>
+                    <a:lstStyle/>
+                    <a:p>
+                      <a:pPr algn="ctr">
+                        <a:defRPr sz="1100" b="1">
+                          <a:solidFill>
+                            <a:srgbClr val="FFFFFF"/>
+                          </a:solidFill>
+                          <a:latin typeface="Arial"/>
+                        </a:defRPr>
+                      </a:pPr>
+                      <a:r>
+                        <a:t>Model Iteration</a:t>
+                      </a:r>
+                    </a:p>
+                  </a:txBody>
+                  <a:tcPr>
+                    <a:solidFill>
+                      <a:srgbClr val="1E3A8A"/>
+                    </a:solidFill>
+                  </a:tcPr>
+                </a:tc>
+                <a:tc>
+                  <a:txBody>
+                    <a:bodyPr/>
+                    <a:lstStyle/>
+                    <a:p>
+                      <a:pPr algn="ctr">
+                        <a:defRPr sz="1100" b="1">
+                          <a:solidFill>
+                            <a:srgbClr val="FFFFFF"/>
+                          </a:solidFill>
+                          <a:latin typeface="Arial"/>
+                        </a:defRPr>
+                      </a:pPr>
+                      <a:r>
+                        <a:t>Dataset / Setup</a:t>
+                      </a:r>
+                    </a:p>
+                  </a:txBody>
+                  <a:tcPr>
+                    <a:solidFill>
+                      <a:srgbClr val="1E3A8A"/>
+                    </a:solidFill>
+                  </a:tcPr>
+                </a:tc>
+                <a:tc>
+                  <a:txBody>
+                    <a:bodyPr/>
+                    <a:lstStyle/>
+                    <a:p>
+                      <a:pPr algn="ctr">
+                        <a:defRPr sz="1100" b="1">
+                          <a:solidFill>
+                            <a:srgbClr val="FFFFFF"/>
+                          </a:solidFill>
+                          <a:latin typeface="Arial"/>
+                        </a:defRPr>
+                      </a:pPr>
+                      <a:r>
+                        <a:t>Train Acc</a:t>
+                      </a:r>
+                    </a:p>
+                  </a:txBody>
+                  <a:tcPr>
+                    <a:solidFill>
+                      <a:srgbClr val="1E3A8A"/>
+                    </a:solidFill>
+                  </a:tcPr>
+                </a:tc>
+                <a:tc>
+                  <a:txBody>
+                    <a:bodyPr/>
+                    <a:lstStyle/>
+                    <a:p>
+                      <a:pPr algn="ctr">
+                        <a:defRPr sz="1100" b="1">
+                          <a:solidFill>
+                            <a:srgbClr val="FFFFFF"/>
+                          </a:solidFill>
+                          <a:latin typeface="Arial"/>
+                        </a:defRPr>
+                      </a:pPr>
+                      <a:r>
+                        <a:t>Val Acc</a:t>
+                      </a:r>
+                    </a:p>
+                  </a:txBody>
+                  <a:tcPr>
+                    <a:solidFill>
+                      <a:srgbClr val="1E3A8A"/>
+                    </a:solidFill>
+                  </a:tcPr>
+                </a:tc>
+                <a:tc>
+                  <a:txBody>
+                    <a:bodyPr/>
+                    <a:lstStyle/>
+                    <a:p>
+                      <a:pPr algn="ctr">
+                        <a:defRPr sz="1100" b="1">
+                          <a:solidFill>
+                            <a:srgbClr val="FFFFFF"/>
+                          </a:solidFill>
+                          <a:latin typeface="Arial"/>
+                        </a:defRPr>
+                      </a:pPr>
+                      <a:r>
+                        <a:t>Test Acc</a:t>
+                      </a:r>
+                    </a:p>
+                  </a:txBody>
+                  <a:tcPr>
+                    <a:solidFill>
+                      <a:srgbClr val="1E3A8A"/>
+                    </a:solidFill>
+                  </a:tcPr>
+                </a:tc>
+                <a:tc>
+                  <a:txBody>
+                    <a:bodyPr/>
+                    <a:lstStyle/>
+                    <a:p>
+                      <a:pPr algn="ctr">
+                        <a:defRPr sz="1100" b="1">
+                          <a:solidFill>
+                            <a:srgbClr val="FFFFFF"/>
+                          </a:solidFill>
+                          <a:latin typeface="Arial"/>
+                        </a:defRPr>
+                      </a:pPr>
+                      <a:r>
+                        <a:t>Weighted F1</a:t>
+                      </a:r>
+                    </a:p>
+                  </a:txBody>
+                  <a:tcPr>
+                    <a:solidFill>
+                      <a:srgbClr val="1E3A8A"/>
+                    </a:solidFill>
+                  </a:tcPr>
+                </a:tc>
+              </a:tr>
+              <a:tr h="762000">
+                <a:tc>
+                  <a:txBody>
+                    <a:bodyPr/>
+                    <a:lstStyle/>
+                    <a:p>
+                      <a:pPr algn="l">
+                        <a:defRPr sz="1050" b="0">
+                          <a:solidFill>
+                            <a:srgbClr val="0F172A"/>
+                          </a:solidFill>
+                          <a:latin typeface="Arial"/>
+                        </a:defRPr>
+                      </a:pPr>
+                      <a:r>
+                        <a:t>1. UCF-Crime 13-Class 3D CNN</a:t>
+                      </a:r>
+                    </a:p>
+                  </a:txBody>
+                  <a:tcPr>
+                    <a:solidFill>
+                      <a:srgbClr val="FFFFFF"/>
+                    </a:solidFill>
+                  </a:tcPr>
+                </a:tc>
+                <a:tc>
+                  <a:txBody>
+                    <a:bodyPr/>
+                    <a:lstStyle/>
+                    <a:p>
+                      <a:pPr algn="ctr">
+                        <a:defRPr sz="1050" b="0">
+                          <a:solidFill>
+                            <a:srgbClr val="0F172A"/>
+                          </a:solidFill>
+                          <a:latin typeface="Arial"/>
+                        </a:defRPr>
+                      </a:pPr>
+                      <a:r>
+                        <a:t>13 Legal Classes</a:t>
+                      </a:r>
+                    </a:p>
+                  </a:txBody>
+                  <a:tcPr>
+                    <a:solidFill>
+                      <a:srgbClr val="FFFFFF"/>
+                    </a:solidFill>
+                  </a:tcPr>
+                </a:tc>
+                <a:tc>
+                  <a:txBody>
+                    <a:bodyPr/>
+                    <a:lstStyle/>
+                    <a:p>
+                      <a:pPr algn="ctr">
+                        <a:defRPr sz="1050" b="0">
+                          <a:solidFill>
+                            <a:srgbClr val="0F172A"/>
+                          </a:solidFill>
+                          <a:latin typeface="Arial"/>
+                        </a:defRPr>
+                      </a:pPr>
+                      <a:r>
+                        <a:t>96.38%</a:t>
+                      </a:r>
+                    </a:p>
+                  </a:txBody>
+                  <a:tcPr>
+                    <a:solidFill>
+                      <a:srgbClr val="FFFFFF"/>
+                    </a:solidFill>
+                  </a:tcPr>
+                </a:tc>
+                <a:tc>
+                  <a:txBody>
+                    <a:bodyPr/>
+                    <a:lstStyle/>
+                    <a:p>
+                      <a:pPr algn="ctr">
+                        <a:defRPr sz="1050" b="0">
+                          <a:solidFill>
+                            <a:srgbClr val="0F172A"/>
+                          </a:solidFill>
+                          <a:latin typeface="Arial"/>
+                        </a:defRPr>
+                      </a:pPr>
+                      <a:r>
+                        <a:t>29.12%</a:t>
+                      </a:r>
+                    </a:p>
+                  </a:txBody>
+                  <a:tcPr>
+                    <a:solidFill>
+                      <a:srgbClr val="FFFFFF"/>
+                    </a:solidFill>
+                  </a:tcPr>
+                </a:tc>
+                <a:tc>
+                  <a:txBody>
+                    <a:bodyPr/>
+                    <a:lstStyle/>
+                    <a:p>
+                      <a:pPr algn="ctr">
+                        <a:defRPr sz="1050" b="0">
+                          <a:solidFill>
+                            <a:srgbClr val="0F172A"/>
+                          </a:solidFill>
+                          <a:latin typeface="Arial"/>
+                        </a:defRPr>
+                      </a:pPr>
+                      <a:r>
+                        <a:t>22.61%</a:t>
+                      </a:r>
+                    </a:p>
+                  </a:txBody>
+                  <a:tcPr>
+                    <a:solidFill>
+                      <a:srgbClr val="FFFFFF"/>
+                    </a:solidFill>
+                  </a:tcPr>
+                </a:tc>
+                <a:tc>
+                  <a:txBody>
+                    <a:bodyPr/>
+                    <a:lstStyle/>
+                    <a:p>
+                      <a:pPr algn="ctr">
+                        <a:defRPr sz="1050" b="0">
+                          <a:solidFill>
+                            <a:srgbClr val="0F172A"/>
+                          </a:solidFill>
+                          <a:latin typeface="Arial"/>
+                        </a:defRPr>
+                      </a:pPr>
+                      <a:r>
+                        <a:t>22.05%</a:t>
+                      </a:r>
+                    </a:p>
+                  </a:txBody>
+                  <a:tcPr>
+                    <a:solidFill>
+                      <a:srgbClr val="FFFFFF"/>
+                    </a:solidFill>
+                  </a:tcPr>
+                </a:tc>
+              </a:tr>
+              <a:tr h="762000">
+                <a:tc>
+                  <a:txBody>
+                    <a:bodyPr/>
+                    <a:lstStyle/>
+                    <a:p>
+                      <a:pPr algn="l">
+                        <a:defRPr sz="1050" b="0">
+                          <a:solidFill>
+                            <a:srgbClr val="0F172A"/>
+                          </a:solidFill>
+                          <a:latin typeface="Arial"/>
+                        </a:defRPr>
+                      </a:pPr>
+                      <a:r>
+                        <a:t>2. UCF-Crime 4-Action Cluster</a:t>
+                      </a:r>
+                    </a:p>
+                  </a:txBody>
+                  <a:tcPr>
+                    <a:solidFill>
+                      <a:srgbClr val="FFFFFF"/>
+                    </a:solidFill>
+                  </a:tcPr>
+                </a:tc>
+                <a:tc>
+                  <a:txBody>
+                    <a:bodyPr/>
+                    <a:lstStyle/>
+                    <a:p>
+                      <a:pPr algn="ctr">
+                        <a:defRPr sz="1050" b="0">
+                          <a:solidFill>
+                            <a:srgbClr val="0F172A"/>
+                          </a:solidFill>
+                          <a:latin typeface="Arial"/>
+                        </a:defRPr>
+                      </a:pPr>
+                      <a:r>
+                        <a:t>4 Action Groups</a:t>
+                      </a:r>
+                    </a:p>
+                  </a:txBody>
+                  <a:tcPr>
+                    <a:solidFill>
+                      <a:srgbClr val="FFFFFF"/>
+                    </a:solidFill>
+                  </a:tcPr>
+                </a:tc>
+                <a:tc>
+                  <a:txBody>
+                    <a:bodyPr/>
+                    <a:lstStyle/>
+                    <a:p>
+                      <a:pPr algn="ctr">
+                        <a:defRPr sz="1050" b="0">
+                          <a:solidFill>
+                            <a:srgbClr val="0F172A"/>
+                          </a:solidFill>
+                          <a:latin typeface="Arial"/>
+                        </a:defRPr>
+                      </a:pPr>
+                      <a:r>
+                        <a:t>98.62%</a:t>
+                      </a:r>
+                    </a:p>
+                  </a:txBody>
+                  <a:tcPr>
+                    <a:solidFill>
+                      <a:srgbClr val="FFFFFF"/>
+                    </a:solidFill>
+                  </a:tcPr>
+                </a:tc>
+                <a:tc>
+                  <a:txBody>
+                    <a:bodyPr/>
+                    <a:lstStyle/>
+                    <a:p>
+                      <a:pPr algn="ctr">
+                        <a:defRPr sz="1050" b="0">
+                          <a:solidFill>
+                            <a:srgbClr val="0F172A"/>
+                          </a:solidFill>
+                          <a:latin typeface="Arial"/>
+                        </a:defRPr>
+                      </a:pPr>
+                      <a:r>
+                        <a:t>56.05%</a:t>
+                      </a:r>
+                    </a:p>
+                  </a:txBody>
+                  <a:tcPr>
+                    <a:solidFill>
+                      <a:srgbClr val="FFFFFF"/>
+                    </a:solidFill>
+                  </a:tcPr>
+                </a:tc>
+                <a:tc>
+                  <a:txBody>
+                    <a:bodyPr/>
+                    <a:lstStyle/>
+                    <a:p>
+                      <a:pPr algn="ctr">
+                        <a:defRPr sz="1050" b="0">
+                          <a:solidFill>
+                            <a:srgbClr val="0F172A"/>
+                          </a:solidFill>
+                          <a:latin typeface="Arial"/>
+                        </a:defRPr>
+                      </a:pPr>
+                      <a:r>
+                        <a:t>52.37%</a:t>
+                      </a:r>
+                    </a:p>
+                  </a:txBody>
+                  <a:tcPr>
+                    <a:solidFill>
+                      <a:srgbClr val="FFFFFF"/>
+                    </a:solidFill>
+                  </a:tcPr>
+                </a:tc>
+                <a:tc>
+                  <a:txBody>
+                    <a:bodyPr/>
+                    <a:lstStyle/>
+                    <a:p>
+                      <a:pPr algn="ctr">
+                        <a:defRPr sz="1050" b="0">
+                          <a:solidFill>
+                            <a:srgbClr val="0F172A"/>
+                          </a:solidFill>
+                          <a:latin typeface="Arial"/>
+                        </a:defRPr>
+                      </a:pPr>
+                      <a:r>
+                        <a:t>51.20%</a:t>
+                      </a:r>
+                    </a:p>
+                  </a:txBody>
+                  <a:tcPr>
+                    <a:solidFill>
+                      <a:srgbClr val="FFFFFF"/>
+                    </a:solidFill>
+                  </a:tcPr>
+                </a:tc>
+              </a:tr>
+              <a:tr h="762000">
+                <a:tc>
+                  <a:txBody>
+                    <a:bodyPr/>
+                    <a:lstStyle/>
+                    <a:p>
+                      <a:pPr algn="l">
+                        <a:defRPr sz="1050" b="0">
+                          <a:solidFill>
+                            <a:srgbClr val="0F172A"/>
+                          </a:solidFill>
+                          <a:latin typeface="Arial"/>
+                        </a:defRPr>
+                      </a:pPr>
+                      <a:r>
+                        <a:t>3. XD Single-Slice ViT</a:t>
+                      </a:r>
+                    </a:p>
+                  </a:txBody>
+                  <a:tcPr>
+                    <a:solidFill>
+                      <a:srgbClr val="FFFFFF"/>
+                    </a:solidFill>
+                  </a:tcPr>
+                </a:tc>
+                <a:tc>
+                  <a:txBody>
+                    <a:bodyPr/>
+                    <a:lstStyle/>
+                    <a:p>
+                      <a:pPr algn="ctr">
+                        <a:defRPr sz="1050" b="0">
+                          <a:solidFill>
+                            <a:srgbClr val="0F172A"/>
+                          </a:solidFill>
+                          <a:latin typeface="Arial"/>
+                        </a:defRPr>
+                      </a:pPr>
+                      <a:r>
+                        <a:t>6 Action Classes</a:t>
+                      </a:r>
+                    </a:p>
+                  </a:txBody>
+                  <a:tcPr>
+                    <a:solidFill>
+                      <a:srgbClr val="FFFFFF"/>
+                    </a:solidFill>
+                  </a:tcPr>
+                </a:tc>
+                <a:tc>
+                  <a:txBody>
+                    <a:bodyPr/>
+                    <a:lstStyle/>
+                    <a:p>
+                      <a:pPr algn="ctr">
+                        <a:defRPr sz="1050" b="0">
+                          <a:solidFill>
+                            <a:srgbClr val="0F172A"/>
+                          </a:solidFill>
+                          <a:latin typeface="Arial"/>
+                        </a:defRPr>
+                      </a:pPr>
+                      <a:r>
+                        <a:t>72.99%</a:t>
+                      </a:r>
+                    </a:p>
+                  </a:txBody>
+                  <a:tcPr>
+                    <a:solidFill>
+                      <a:srgbClr val="FFFFFF"/>
+                    </a:solidFill>
+                  </a:tcPr>
+                </a:tc>
+                <a:tc>
+                  <a:txBody>
+                    <a:bodyPr/>
+                    <a:lstStyle/>
+                    <a:p>
+                      <a:pPr algn="ctr">
+                        <a:defRPr sz="1050" b="0">
+                          <a:solidFill>
+                            <a:srgbClr val="0F172A"/>
+                          </a:solidFill>
+                          <a:latin typeface="Arial"/>
+                        </a:defRPr>
+                      </a:pPr>
+                      <a:r>
+                        <a:t>66.82%</a:t>
+                      </a:r>
+                    </a:p>
+                  </a:txBody>
+                  <a:tcPr>
+                    <a:solidFill>
+                      <a:srgbClr val="FFFFFF"/>
+                    </a:solidFill>
+                  </a:tcPr>
+                </a:tc>
+                <a:tc>
+                  <a:txBody>
+                    <a:bodyPr/>
+                    <a:lstStyle/>
+                    <a:p>
+                      <a:pPr algn="ctr">
+                        <a:defRPr sz="1050" b="0">
+                          <a:solidFill>
+                            <a:srgbClr val="0F172A"/>
+                          </a:solidFill>
+                          <a:latin typeface="Arial"/>
+                        </a:defRPr>
+                      </a:pPr>
+                      <a:r>
+                        <a:t>71.23%</a:t>
+                      </a:r>
+                    </a:p>
+                  </a:txBody>
+                  <a:tcPr>
+                    <a:solidFill>
+                      <a:srgbClr val="FFFFFF"/>
+                    </a:solidFill>
+                  </a:tcPr>
+                </a:tc>
+                <a:tc>
+                  <a:txBody>
+                    <a:bodyPr/>
+                    <a:lstStyle/>
+                    <a:p>
+                      <a:pPr algn="ctr">
+                        <a:defRPr sz="1050" b="0">
+                          <a:solidFill>
+                            <a:srgbClr val="0F172A"/>
+                          </a:solidFill>
+                          <a:latin typeface="Arial"/>
+                        </a:defRPr>
+                      </a:pPr>
+                      <a:r>
+                        <a:t>71.41%</a:t>
+                      </a:r>
+                    </a:p>
+                  </a:txBody>
+                  <a:tcPr>
+                    <a:solidFill>
+                      <a:srgbClr val="FFFFFF"/>
+                    </a:solidFill>
+                  </a:tcPr>
+                </a:tc>
+              </a:tr>
+              <a:tr h="762000">
+                <a:tc>
+                  <a:txBody>
+                    <a:bodyPr/>
+                    <a:lstStyle/>
+                    <a:p>
+                      <a:pPr algn="l">
+                        <a:defRPr sz="1050" b="1">
+                          <a:solidFill>
+                            <a:srgbClr val="16A34A"/>
+                          </a:solidFill>
+                          <a:latin typeface="Arial"/>
+                        </a:defRPr>
+                      </a:pPr>
+                      <a:r>
+                        <a:t>4. Refined TSN-VideoViT (USM) 🏆</a:t>
+                      </a:r>
+                    </a:p>
+                  </a:txBody>
+                  <a:tcPr>
+                    <a:solidFill>
+                      <a:srgbClr val="F0FDF4"/>
+                    </a:solidFill>
+                  </a:tcPr>
+                </a:tc>
+                <a:tc>
+                  <a:txBody>
+                    <a:bodyPr/>
+                    <a:lstStyle/>
+                    <a:p>
+                      <a:pPr algn="ctr">
+                        <a:defRPr sz="1050" b="1">
+                          <a:solidFill>
+                            <a:srgbClr val="16A34A"/>
+                          </a:solidFill>
+                          <a:latin typeface="Arial"/>
+                        </a:defRPr>
+                      </a:pPr>
+                      <a:r>
+                        <a:t>6 Action Classes</a:t>
+                      </a:r>
+                    </a:p>
+                  </a:txBody>
+                  <a:tcPr>
+                    <a:solidFill>
+                      <a:srgbClr val="F0FDF4"/>
+                    </a:solidFill>
+                  </a:tcPr>
+                </a:tc>
+                <a:tc>
+                  <a:txBody>
+                    <a:bodyPr/>
+                    <a:lstStyle/>
+                    <a:p>
+                      <a:pPr algn="ctr">
+                        <a:defRPr sz="1050" b="1">
+                          <a:solidFill>
+                            <a:srgbClr val="16A34A"/>
+                          </a:solidFill>
+                          <a:latin typeface="Arial"/>
+                        </a:defRPr>
+                      </a:pPr>
+                      <a:r>
+                        <a:t>94.46%</a:t>
+                      </a:r>
+                    </a:p>
+                  </a:txBody>
+                  <a:tcPr>
+                    <a:solidFill>
+                      <a:srgbClr val="F0FDF4"/>
+                    </a:solidFill>
+                  </a:tcPr>
+                </a:tc>
+                <a:tc>
+                  <a:txBody>
+                    <a:bodyPr/>
+                    <a:lstStyle/>
+                    <a:p>
+                      <a:pPr algn="ctr">
+                        <a:defRPr sz="1050" b="1">
+                          <a:solidFill>
+                            <a:srgbClr val="16A34A"/>
+                          </a:solidFill>
+                          <a:latin typeface="Arial"/>
+                        </a:defRPr>
+                      </a:pPr>
+                      <a:r>
+                        <a:t>79.15%</a:t>
+                      </a:r>
+                    </a:p>
+                  </a:txBody>
+                  <a:tcPr>
+                    <a:solidFill>
+                      <a:srgbClr val="F0FDF4"/>
+                    </a:solidFill>
+                  </a:tcPr>
+                </a:tc>
+                <a:tc>
+                  <a:txBody>
+                    <a:bodyPr/>
+                    <a:lstStyle/>
+                    <a:p>
+                      <a:pPr algn="ctr">
+                        <a:defRPr sz="1050" b="1">
+                          <a:solidFill>
+                            <a:srgbClr val="16A34A"/>
+                          </a:solidFill>
+                          <a:latin typeface="Arial"/>
+                        </a:defRPr>
+                      </a:pPr>
+                      <a:r>
+                        <a:t>77.36%</a:t>
+                      </a:r>
+                    </a:p>
+                  </a:txBody>
+                  <a:tcPr>
+                    <a:solidFill>
+                      <a:srgbClr val="F0FDF4"/>
+                    </a:solidFill>
+                  </a:tcPr>
+                </a:tc>
+                <a:tc>
+                  <a:txBody>
+                    <a:bodyPr/>
+                    <a:lstStyle/>
+                    <a:p>
+                      <a:pPr algn="ctr">
+                        <a:defRPr sz="1050" b="1">
+                          <a:solidFill>
+                            <a:srgbClr val="16A34A"/>
+                          </a:solidFill>
+                          <a:latin typeface="Arial"/>
+                        </a:defRPr>
+                      </a:pPr>
+                      <a:r>
+                        <a:t>77.61%</a:t>
+                      </a:r>
+                    </a:p>
+                  </a:txBody>
+                  <a:tcPr>
+                    <a:solidFill>
+                      <a:srgbClr val="F0FDF4"/>
+                    </a:solidFill>
+                  </a:tcPr>
+                </a:tc>
+              </a:tr>
+              <a:tr h="762000">
+                <a:tc>
+                  <a:txBody>
+                    <a:bodyPr/>
+                    <a:lstStyle/>
+                    <a:p>
+                      <a:pPr algn="l">
+                        <a:defRPr sz="1050" b="0">
+                          <a:solidFill>
+                            <a:srgbClr val="0F172A"/>
+                          </a:solidFill>
+                          <a:latin typeface="Arial"/>
+                        </a:defRPr>
+                      </a:pPr>
+                      <a:r>
+                        <a:t>5. Dual-Stream Motion ViT</a:t>
+                      </a:r>
+                    </a:p>
+                  </a:txBody>
+                  <a:tcPr>
+                    <a:solidFill>
+                      <a:srgbClr val="FFFFFF"/>
+                    </a:solidFill>
+                  </a:tcPr>
+                </a:tc>
+                <a:tc>
+                  <a:txBody>
+                    <a:bodyPr/>
+                    <a:lstStyle/>
+                    <a:p>
+                      <a:pPr algn="ctr">
+                        <a:defRPr sz="1050" b="0">
+                          <a:solidFill>
+                            <a:srgbClr val="0F172A"/>
+                          </a:solidFill>
+                          <a:latin typeface="Arial"/>
+                        </a:defRPr>
+                      </a:pPr>
+                      <a:r>
+                        <a:t>Dual Stream Zoom</a:t>
+                      </a:r>
+                    </a:p>
+                  </a:txBody>
+                  <a:tcPr>
+                    <a:solidFill>
+                      <a:srgbClr val="FFFFFF"/>
+                    </a:solidFill>
+                  </a:tcPr>
+                </a:tc>
+                <a:tc>
+                  <a:txBody>
+                    <a:bodyPr/>
+                    <a:lstStyle/>
+                    <a:p>
+                      <a:pPr algn="ctr">
+                        <a:defRPr sz="1050" b="0">
+                          <a:solidFill>
+                            <a:srgbClr val="0F172A"/>
+                          </a:solidFill>
+                          <a:latin typeface="Arial"/>
+                        </a:defRPr>
+                      </a:pPr>
+                      <a:r>
+                        <a:t>96.24%</a:t>
+                      </a:r>
+                    </a:p>
+                  </a:txBody>
+                  <a:tcPr>
+                    <a:solidFill>
+                      <a:srgbClr val="FFFFFF"/>
+                    </a:solidFill>
+                  </a:tcPr>
+                </a:tc>
+                <a:tc>
+                  <a:txBody>
+                    <a:bodyPr/>
+                    <a:lstStyle/>
+                    <a:p>
+                      <a:pPr algn="ctr">
+                        <a:defRPr sz="1050" b="0">
+                          <a:solidFill>
+                            <a:srgbClr val="0F172A"/>
+                          </a:solidFill>
+                          <a:latin typeface="Arial"/>
+                        </a:defRPr>
+                      </a:pPr>
+                      <a:r>
+                        <a:t>76.78%</a:t>
+                      </a:r>
+                    </a:p>
+                  </a:txBody>
+                  <a:tcPr>
+                    <a:solidFill>
+                      <a:srgbClr val="FFFFFF"/>
+                    </a:solidFill>
+                  </a:tcPr>
+                </a:tc>
+                <a:tc>
+                  <a:txBody>
+                    <a:bodyPr/>
+                    <a:lstStyle/>
+                    <a:p>
+                      <a:pPr algn="ctr">
+                        <a:defRPr sz="1050" b="0">
+                          <a:solidFill>
+                            <a:srgbClr val="0F172A"/>
+                          </a:solidFill>
+                          <a:latin typeface="Arial"/>
+                        </a:defRPr>
+                      </a:pPr>
+                      <a:r>
+                        <a:t>77.04%</a:t>
+                      </a:r>
+                    </a:p>
+                  </a:txBody>
+                  <a:tcPr>
+                    <a:solidFill>
+                      <a:srgbClr val="FFFFFF"/>
+                    </a:solidFill>
+                  </a:tcPr>
+                </a:tc>
+                <a:tc>
+                  <a:txBody>
+                    <a:bodyPr/>
+                    <a:lstStyle/>
+                    <a:p>
+                      <a:pPr algn="ctr">
+                        <a:defRPr sz="1050" b="0">
+                          <a:solidFill>
+                            <a:srgbClr val="0F172A"/>
+                          </a:solidFill>
+                          <a:latin typeface="Arial"/>
+                        </a:defRPr>
+                      </a:pPr>
+                      <a:r>
+                        <a:t>77.31%</a:t>
+                      </a:r>
+                    </a:p>
+                  </a:txBody>
+                  <a:tcPr>
+                    <a:solidFill>
+                      <a:srgbClr val="FFFFFF"/>
+                    </a:solidFill>
+                  </a:tcPr>
+                </a:tc>
+              </a:tr>
+            </a:tbl>
+          </a:graphicData>
+        </a:graphic>
+      </p:graphicFrame>
+    </p:spTree>
+  </p:cSld>
+  <p:clrMapOvr>
+    <a:masterClrMapping/>
+  </p:clrMapOvr>
+</p:sld>
+</file>
+
+<file path=ppt/slides/slide9.xml><?xml version="1.0" encoding="utf-8"?>
+<p:sld xmlns:a="http://schemas.openxmlformats.org/drawingml/2006/main" xmlns:p="http://schemas.openxmlformats.org/presentationml/2006/main" xmlns:r="http://schemas.openxmlformats.org/officeDocument/2006/relationships">
+  <p:cSld>
+    <p:spTree>
+      <p:nvGrpSpPr>
+        <p:cNvPr id="1" name=""/>
+        <p:cNvGrpSpPr/>
+        <p:nvPr/>
+      </p:nvGrpSpPr>
+      <p:grpSpPr/>
+      <p:sp>
+        <p:nvSpPr>
+          <p:cNvPr id="2" name="TextBox 1"/>
+          <p:cNvSpPr txBox="1"/>
+          <p:nvPr/>
+        </p:nvSpPr>
+        <p:spPr>
+          <a:xfrm>
+            <a:off x="731520" y="365760"/>
+            <a:ext cx="10698480" cy="1005840"/>
+          </a:xfrm>
+          <a:prstGeom prst="rect">
+            <a:avLst/>
+          </a:prstGeom>
+          <a:noFill/>
+        </p:spPr>
+        <p:txBody>
+          <a:bodyPr wrap="square" lIns="0" tIns="0" rIns="0" bIns="0">
+            <a:spAutoFit/>
+          </a:bodyPr>
+          <a:lstStyle/>
+          <a:p>
+            <a:pPr>
+              <a:defRPr sz="1000" b="1">
+                <a:solidFill>
+                  <a:srgbClr val="1E3A8A"/>
+                </a:solidFill>
+                <a:latin typeface="Arial"/>
+              </a:defRPr>
+            </a:pPr>
+            <a:r>
+              <a:t>5. PHASE 2 CLASS ANALYSIS</a:t>
+            </a:r>
+          </a:p>
+          <a:p>
+            <a:pPr>
+              <a:defRPr sz="2200" b="1">
+                <a:solidFill>
+                  <a:srgbClr val="0F172A"/>
+                </a:solidFill>
+                <a:latin typeface="Arial"/>
+              </a:defRPr>
+            </a:pPr>
+            <a:r>
+              <a:t>Phase 2 Per-Class Breakdown &amp; Confusion Matrix Analysis</a:t>
             </a:r>
           </a:p>
         </p:txBody>
@@ -9755,363 +11082,6 @@
           </a:graphicData>
         </a:graphic>
       </p:graphicFrame>
-    </p:spTree>
-  </p:cSld>
-  <p:clrMapOvr>
-    <a:masterClrMapping/>
-  </p:clrMapOvr>
-</p:sld>
-</file>
-
-<file path=ppt/slides/slide9.xml><?xml version="1.0" encoding="utf-8"?>
-<p:sld xmlns:a="http://schemas.openxmlformats.org/drawingml/2006/main" xmlns:p="http://schemas.openxmlformats.org/presentationml/2006/main" xmlns:r="http://schemas.openxmlformats.org/officeDocument/2006/relationships">
-  <p:cSld>
-    <p:spTree>
-      <p:nvGrpSpPr>
-        <p:cNvPr id="1" name=""/>
-        <p:cNvGrpSpPr/>
-        <p:nvPr/>
-      </p:nvGrpSpPr>
-      <p:grpSpPr/>
-      <p:sp>
-        <p:nvSpPr>
-          <p:cNvPr id="2" name="TextBox 1"/>
-          <p:cNvSpPr txBox="1"/>
-          <p:nvPr/>
-        </p:nvSpPr>
-        <p:spPr>
-          <a:xfrm>
-            <a:off x="731520" y="365760"/>
-            <a:ext cx="10698480" cy="1005840"/>
-          </a:xfrm>
-          <a:prstGeom prst="rect">
-            <a:avLst/>
-          </a:prstGeom>
-          <a:noFill/>
-        </p:spPr>
-        <p:txBody>
-          <a:bodyPr wrap="square" lIns="0" tIns="0" rIns="0" bIns="0">
-            <a:spAutoFit/>
-          </a:bodyPr>
-          <a:lstStyle/>
-          <a:p>
-            <a:pPr>
-              <a:defRPr sz="1000" b="1">
-                <a:solidFill>
-                  <a:srgbClr val="1E3A8A"/>
-                </a:solidFill>
-                <a:latin typeface="Arial"/>
-              </a:defRPr>
-            </a:pPr>
-            <a:r>
-              <a:t>6. EVIDENCE LOCALIZATION</a:t>
-            </a:r>
-          </a:p>
-          <a:p>
-            <a:pPr>
-              <a:defRPr sz="2200" b="1">
-                <a:solidFill>
-                  <a:srgbClr val="0F172A"/>
-                </a:solidFill>
-                <a:latin typeface="Arial"/>
-              </a:defRPr>
-            </a:pPr>
-            <a:r>
-              <a:t>Phase 3A: YOLOv8 Weapon Detection &amp; Bayesian Fusion</a:t>
-            </a:r>
-          </a:p>
-        </p:txBody>
-      </p:sp>
-      <p:sp>
-        <p:nvSpPr>
-          <p:cNvPr id="3" name="Rounded Rectangle 2"/>
-          <p:cNvSpPr/>
-          <p:nvPr/>
-        </p:nvSpPr>
-        <p:spPr>
-          <a:xfrm>
-            <a:off x="731520" y="1463040"/>
-            <a:ext cx="5120640" cy="4754880"/>
-          </a:xfrm>
-          <a:prstGeom prst="roundRect">
-            <a:avLst/>
-          </a:prstGeom>
-          <a:solidFill>
-            <a:srgbClr val="F1F5F9"/>
-          </a:solidFill>
-          <a:ln w="12700">
-            <a:solidFill>
-              <a:srgbClr val="CBD5E1"/>
-            </a:solidFill>
-          </a:ln>
-        </p:spPr>
-        <p:style>
-          <a:lnRef idx="1">
-            <a:schemeClr val="accent1"/>
-          </a:lnRef>
-          <a:fillRef idx="3">
-            <a:schemeClr val="accent1"/>
-          </a:fillRef>
-          <a:effectRef idx="2">
-            <a:schemeClr val="accent1"/>
-          </a:effectRef>
-          <a:fontRef idx="minor">
-            <a:schemeClr val="lt1"/>
-          </a:fontRef>
-        </p:style>
-        <p:txBody>
-          <a:bodyPr rtlCol="0" anchor="ctr"/>
-          <a:lstStyle/>
-          <a:p>
-            <a:pPr algn="ctr"/>
-          </a:p>
-        </p:txBody>
-      </p:sp>
-      <p:sp>
-        <p:nvSpPr>
-          <p:cNvPr id="4" name="TextBox 3"/>
-          <p:cNvSpPr txBox="1"/>
-          <p:nvPr/>
-        </p:nvSpPr>
-        <p:spPr>
-          <a:xfrm>
-            <a:off x="1005840" y="1737360"/>
-            <a:ext cx="4572000" cy="4206240"/>
-          </a:xfrm>
-          <a:prstGeom prst="rect">
-            <a:avLst/>
-          </a:prstGeom>
-          <a:noFill/>
-        </p:spPr>
-        <p:txBody>
-          <a:bodyPr wrap="square">
-            <a:spAutoFit/>
-          </a:bodyPr>
-          <a:lstStyle/>
-          <a:p>
-            <a:pPr>
-              <a:defRPr sz="1500" b="1">
-                <a:solidFill>
-                  <a:srgbClr val="DC2626"/>
-                </a:solidFill>
-                <a:latin typeface="Arial"/>
-              </a:defRPr>
-            </a:pPr>
-            <a:r>
-              <a:t>🔪 Real-Time Lethal Weapon Detection</a:t>
-            </a:r>
-          </a:p>
-          <a:p>
-            <a:pPr>
-              <a:spcBef>
-                <a:spcPts val="800"/>
-              </a:spcBef>
-              <a:defRPr sz="1150">
-                <a:solidFill>
-                  <a:srgbClr val="0F172A"/>
-                </a:solidFill>
-                <a:latin typeface="Arial"/>
-              </a:defRPr>
-            </a:pPr>
-            <a:r>
-              <a:t>• Model: Ultralytics YOLOv8 real-time anchor-free detector with Path Aggregation Network (PANet).</a:t>
-            </a:r>
-          </a:p>
-          <a:p>
-            <a:pPr>
-              <a:spcBef>
-                <a:spcPts val="800"/>
-              </a:spcBef>
-              <a:defRPr sz="1150">
-                <a:solidFill>
-                  <a:srgbClr val="0F172A"/>
-                </a:solidFill>
-                <a:latin typeface="Arial"/>
-              </a:defRPr>
-            </a:pPr>
-            <a:r>
-              <a:t>• Target Classes: Firearms, Pistols, Revolvers, Knives, Daggers, Machetes, Baseball Bats.</a:t>
-            </a:r>
-          </a:p>
-          <a:p>
-            <a:pPr>
-              <a:spcBef>
-                <a:spcPts val="800"/>
-              </a:spcBef>
-              <a:defRPr sz="1150">
-                <a:solidFill>
-                  <a:srgbClr val="0F172A"/>
-                </a:solidFill>
-                <a:latin typeface="Arial"/>
-              </a:defRPr>
-            </a:pPr>
-            <a:r>
-              <a:t>• Keyframe Analysis: Evaluates top 3 peak motion keyframes when Phase 1 gate triggers threat.</a:t>
-            </a:r>
-          </a:p>
-          <a:p>
-            <a:pPr>
-              <a:spcBef>
-                <a:spcPts val="800"/>
-              </a:spcBef>
-              <a:defRPr sz="1150">
-                <a:solidFill>
-                  <a:srgbClr val="0F172A"/>
-                </a:solidFill>
-                <a:latin typeface="Arial"/>
-              </a:defRPr>
-            </a:pPr>
-            <a:r>
-              <a:t>• Forensic Evidence Cropping: Weapon bounding boxes are saved as isolated images in `incident_evidence/weapon_crops/`.</a:t>
-            </a:r>
-          </a:p>
-        </p:txBody>
-      </p:sp>
-      <p:sp>
-        <p:nvSpPr>
-          <p:cNvPr id="5" name="Rounded Rectangle 4"/>
-          <p:cNvSpPr/>
-          <p:nvPr/>
-        </p:nvSpPr>
-        <p:spPr>
-          <a:xfrm>
-            <a:off x="6309360" y="1463040"/>
-            <a:ext cx="5120640" cy="4754880"/>
-          </a:xfrm>
-          <a:prstGeom prst="roundRect">
-            <a:avLst/>
-          </a:prstGeom>
-          <a:solidFill>
-            <a:srgbClr val="F1F5F9"/>
-          </a:solidFill>
-          <a:ln w="12700">
-            <a:solidFill>
-              <a:srgbClr val="CBD5E1"/>
-            </a:solidFill>
-          </a:ln>
-        </p:spPr>
-        <p:style>
-          <a:lnRef idx="1">
-            <a:schemeClr val="accent1"/>
-          </a:lnRef>
-          <a:fillRef idx="3">
-            <a:schemeClr val="accent1"/>
-          </a:fillRef>
-          <a:effectRef idx="2">
-            <a:schemeClr val="accent1"/>
-          </a:effectRef>
-          <a:fontRef idx="minor">
-            <a:schemeClr val="lt1"/>
-          </a:fontRef>
-        </p:style>
-        <p:txBody>
-          <a:bodyPr rtlCol="0" anchor="ctr"/>
-          <a:lstStyle/>
-          <a:p>
-            <a:pPr algn="ctr"/>
-          </a:p>
-        </p:txBody>
-      </p:sp>
-      <p:sp>
-        <p:nvSpPr>
-          <p:cNvPr id="6" name="TextBox 5"/>
-          <p:cNvSpPr txBox="1"/>
-          <p:nvPr/>
-        </p:nvSpPr>
-        <p:spPr>
-          <a:xfrm>
-            <a:off x="6583680" y="1737360"/>
-            <a:ext cx="4572000" cy="4206240"/>
-          </a:xfrm>
-          <a:prstGeom prst="rect">
-            <a:avLst/>
-          </a:prstGeom>
-          <a:noFill/>
-        </p:spPr>
-        <p:txBody>
-          <a:bodyPr wrap="square">
-            <a:spAutoFit/>
-          </a:bodyPr>
-          <a:lstStyle/>
-          <a:p>
-            <a:pPr>
-              <a:defRPr sz="1500" b="1">
-                <a:solidFill>
-                  <a:srgbClr val="1E3A8A"/>
-                </a:solidFill>
-                <a:latin typeface="Arial"/>
-              </a:defRPr>
-            </a:pPr>
-            <a:r>
-              <a:t>⚡ Cross-Modal Decision Fusion</a:t>
-            </a:r>
-          </a:p>
-          <a:p>
-            <a:pPr>
-              <a:spcBef>
-                <a:spcPts val="800"/>
-              </a:spcBef>
-              <a:defRPr sz="1150">
-                <a:solidFill>
-                  <a:srgbClr val="0F172A"/>
-                </a:solidFill>
-                <a:latin typeface="Arial"/>
-              </a:defRPr>
-            </a:pPr>
-            <a:r>
-              <a:t>• The Shooting Ambiguity Problem: In distant CCTV, small handguns visually resemble fistfights.</a:t>
-            </a:r>
-          </a:p>
-          <a:p>
-            <a:pPr>
-              <a:spcBef>
-                <a:spcPts val="800"/>
-              </a:spcBef>
-              <a:defRPr sz="1150">
-                <a:solidFill>
-                  <a:srgbClr val="0F172A"/>
-                </a:solidFill>
-                <a:latin typeface="Arial"/>
-              </a:defRPr>
-            </a:pPr>
-            <a:r>
-              <a:t>• Bayesian Cross-Modal Fusion: If YOLOv8 detects a firearm with confidence &gt; 0.40, Phase 2 shooting confidence is elevated to &gt; 95%.</a:t>
-            </a:r>
-          </a:p>
-          <a:p>
-            <a:pPr>
-              <a:spcBef>
-                <a:spcPts val="800"/>
-              </a:spcBef>
-              <a:defRPr sz="1150">
-                <a:solidFill>
-                  <a:srgbClr val="0F172A"/>
-                </a:solidFill>
-                <a:latin typeface="Arial"/>
-              </a:defRPr>
-            </a:pPr>
-            <a:r>
-              <a:t>• Armed Brawl Reclassification: If bladed weapons are detected during a physical fight, the event is re-classified as 'Armed Assault'.</a:t>
-            </a:r>
-          </a:p>
-          <a:p>
-            <a:pPr>
-              <a:spcBef>
-                <a:spcPts val="800"/>
-              </a:spcBef>
-              <a:defRPr sz="1150">
-                <a:solidFill>
-                  <a:srgbClr val="0F172A"/>
-                </a:solidFill>
-                <a:latin typeface="Arial"/>
-              </a:defRPr>
-            </a:pPr>
-            <a:r>
-              <a:t>• Performance Impact: Multi-modal fusion elevates real-world shooting/armed precision from 51.9% to over 95%.</a:t>
-            </a:r>
-          </a:p>
-        </p:txBody>
-      </p:sp>
     </p:spTree>
   </p:cSld>
   <p:clrMapOvr>

</xml_diff>